<commit_message>
Integrate Zixun cleaning results and refreshed metrics
</commit_message>
<xml_diff>
--- a/deliverables/final_solution_2026_06_24/PromoMind_final_presentation_zh.pptx
+++ b/deliverables/final_solution_2026_06_24/PromoMind_final_presentation_zh.pptx
@@ -2083,13 +2083,13 @@
               <c:formatCode>0.0</c:formatCode>
               <c:ptCount val="3"/>
               <c:pt idx="0">
-                <c:v>0.4187</c:v>
+                <c:v>0.4138</c:v>
               </c:pt>
               <c:pt idx="1">
-                <c:v>0.3304</c:v>
+                <c:v>0.3225</c:v>
               </c:pt>
               <c:pt idx="2">
-                <c:v>0.5413</c:v>
+                <c:v>0.5321</c:v>
               </c:pt>
             </c:numLit>
           </c:val>
@@ -2522,7 +2522,7 @@
                   <a:srgbClr val="0F766E"/>
                 </a:solidFill>
               </a:rPr>
-              <a:t>0.4187</a:t>
+              <a:t>0.4138</a:t>
             </a:r>
           </a:p>
         </p:txBody>
@@ -2663,7 +2663,7 @@
                   <a:srgbClr val="EA6B5A"/>
                 </a:solidFill>
               </a:rPr>
-              <a:t>0.3304</a:t>
+              <a:t>0.3225</a:t>
             </a:r>
           </a:p>
         </p:txBody>
@@ -2804,7 +2804,7 @@
                   <a:srgbClr val="1F8A5B"/>
                 </a:solidFill>
               </a:rPr>
-              <a:t>54.13%</a:t>
+              <a:t>53.21%</a:t>
             </a:r>
           </a:p>
         </p:txBody>
@@ -9755,7 +9755,7 @@
                   <a:srgbClr val="0F766E"/>
                 </a:solidFill>
               </a:rPr>
-              <a:t>0.5207</a:t>
+              <a:t>0.5184</a:t>
             </a:r>
           </a:p>
         </p:txBody>
@@ -9896,7 +9896,7 @@
                   <a:srgbClr val="EA6B5A"/>
                 </a:solidFill>
               </a:rPr>
-              <a:t>0.3594</a:t>
+              <a:t>0.3520</a:t>
             </a:r>
           </a:p>
         </p:txBody>
@@ -9996,7 +9996,7 @@
                   <a:srgbClr val="18212B"/>
                 </a:solidFill>
               </a:rPr>
-              <a:t>Positive Event Hit@10 从 19.27% 提升至 54.13%。</a:t>
+              <a:t>Positive Event Hit@10 从 18.35% 提升至 53.21%。</a:t>
             </a:r>
           </a:p>
         </p:txBody>

</xml_diff>